<commit_message>
Fix founder name spellings and minor textual errors
- "Minhaj Eshwaramangalam" corrected to "Minhaj Eswaramangalam"
- "Pallampettivelayudhan Nithin" corrected to "Nithin Pallampetti
  Velayudhan" (given name first, surname split)
- Applied across the business plan PDF and the pitch deck: cover
  pages, team tables, cap table, and the data protection officer line.
- Reworded the landlord commission line so the 6% rate is no longer
  ambiguous with the 5% revenue-mix share shown in the deck.
- Removed a stray double space; deck footer now reads "Pitch Deck".

https://claude.ai/code/session_017X5CS7soyc6McUSsjwCrFH
</commit_message>
<xml_diff>
--- a/Euronest_Pitch_Deck.pptx
+++ b/Euronest_Pitch_Deck.pptx
@@ -3725,7 +3725,7 @@
                 </a:solidFill>
                 <a:latin typeface="Calibri"/>
               </a:rPr>
-              <a:t>Minhaj Eshwaramangalam  ·  Gopinath Dasan  ·  Pallampettivelayudhan Nithin</a:t>
+              <a:t>Minhaj Eswaramangalam  ·  Gopinath Dasan  ·  Nithin Pallampetti Velayudhan</a:t>
             </a:r>
           </a:p>
         </p:txBody>
@@ -5109,7 +5109,7 @@
                 </a:solidFill>
                 <a:latin typeface="Calibri"/>
               </a:rPr>
-              <a:t>Euronest  |  Business Plan  |  April 2026</a:t>
+              <a:t>Euronest  |  Pitch Deck  |  April 2026</a:t>
             </a:r>
           </a:p>
         </p:txBody>
@@ -6212,7 +6212,7 @@
                 </a:solidFill>
                 <a:latin typeface="Calibri"/>
               </a:rPr>
-              <a:t>Euronest  |  Business Plan  |  April 2026</a:t>
+              <a:t>Euronest  |  Pitch Deck  |  April 2026</a:t>
             </a:r>
           </a:p>
         </p:txBody>
@@ -6754,7 +6754,7 @@
                 </a:solidFill>
                 <a:latin typeface="Calibri"/>
               </a:rPr>
-              <a:t>Euronest  |  Business Plan  |  April 2026</a:t>
+              <a:t>Euronest  |  Pitch Deck  |  April 2026</a:t>
             </a:r>
           </a:p>
         </p:txBody>
@@ -8150,7 +8150,7 @@
                 </a:solidFill>
                 <a:latin typeface="Calibri"/>
               </a:rPr>
-              <a:t>Euronest  |  Business Plan  |  April 2026</a:t>
+              <a:t>Euronest  |  Pitch Deck  |  April 2026</a:t>
             </a:r>
           </a:p>
         </p:txBody>
@@ -9364,7 +9364,7 @@
                 </a:solidFill>
                 <a:latin typeface="Calibri"/>
               </a:rPr>
-              <a:t>Minhaj Eshwaramangalam</a:t>
+              <a:t>Minhaj Eswaramangalam</a:t>
             </a:r>
           </a:p>
         </p:txBody>
@@ -9774,7 +9774,7 @@
                 </a:solidFill>
                 <a:latin typeface="Calibri"/>
               </a:rPr>
-              <a:t>Pallampettivelayudhan Nithin</a:t>
+              <a:t>Nithin Pallampetti Velayudhan</a:t>
             </a:r>
           </a:p>
         </p:txBody>
@@ -9891,7 +9891,7 @@
                 </a:solidFill>
                 <a:latin typeface="Calibri"/>
               </a:rPr>
-              <a:t>Euronest  |  Business Plan  |  April 2026</a:t>
+              <a:t>Euronest  |  Pitch Deck  |  April 2026</a:t>
             </a:r>
           </a:p>
         </p:txBody>
@@ -11002,7 +11002,7 @@
                 </a:solidFill>
                 <a:latin typeface="Calibri"/>
               </a:rPr>
-              <a:t>Euronest  |  Business Plan  |  April 2026</a:t>
+              <a:t>Euronest  |  Pitch Deck  |  April 2026</a:t>
             </a:r>
           </a:p>
         </p:txBody>
@@ -12508,7 +12508,7 @@
                 </a:solidFill>
                 <a:latin typeface="Calibri"/>
               </a:rPr>
-              <a:t>Euronest  |  Business Plan  |  April 2026</a:t>
+              <a:t>Euronest  |  Pitch Deck  |  April 2026</a:t>
             </a:r>
           </a:p>
         </p:txBody>
@@ -13297,7 +13297,7 @@
                 </a:solidFill>
                 <a:latin typeface="Calibri"/>
               </a:rPr>
-              <a:t>Euronest  |  Business Plan  |  April 2026</a:t>
+              <a:t>Euronest  |  Pitch Deck  |  April 2026</a:t>
             </a:r>
           </a:p>
         </p:txBody>
@@ -15100,7 +15100,7 @@
                 </a:solidFill>
                 <a:latin typeface="Calibri"/>
               </a:rPr>
-              <a:t>Euronest  |  Business Plan  |  April 2026</a:t>
+              <a:t>Euronest  |  Pitch Deck  |  April 2026</a:t>
             </a:r>
           </a:p>
         </p:txBody>
@@ -16109,7 +16109,7 @@
                 </a:solidFill>
                 <a:latin typeface="Calibri"/>
               </a:rPr>
-              <a:t>Euronest  |  Business Plan  |  April 2026</a:t>
+              <a:t>Euronest  |  Pitch Deck  |  April 2026</a:t>
             </a:r>
           </a:p>
         </p:txBody>
@@ -16952,7 +16952,7 @@
                 </a:solidFill>
                 <a:latin typeface="Calibri"/>
               </a:rPr>
-              <a:t>Euronest  |  Business Plan  |  April 2026</a:t>
+              <a:t>Euronest  |  Pitch Deck  |  April 2026</a:t>
             </a:r>
           </a:p>
         </p:txBody>
@@ -17905,7 +17905,7 @@
                 </a:solidFill>
                 <a:latin typeface="Calibri"/>
               </a:rPr>
-              <a:t>Euronest  |  Business Plan  |  April 2026</a:t>
+              <a:t>Euronest  |  Pitch Deck  |  April 2026</a:t>
             </a:r>
           </a:p>
         </p:txBody>
@@ -19236,7 +19236,7 @@
                 </a:solidFill>
                 <a:latin typeface="Calibri"/>
               </a:rPr>
-              <a:t>Euronest  |  Business Plan  |  April 2026</a:t>
+              <a:t>Euronest  |  Pitch Deck  |  April 2026</a:t>
             </a:r>
           </a:p>
         </p:txBody>
@@ -20796,7 +20796,7 @@
                 </a:solidFill>
                 <a:latin typeface="Calibri"/>
               </a:rPr>
-              <a:t>Euronest  |  Business Plan  |  April 2026</a:t>
+              <a:t>Euronest  |  Pitch Deck  |  April 2026</a:t>
             </a:r>
           </a:p>
         </p:txBody>
@@ -22488,7 +22488,7 @@
                 </a:solidFill>
                 <a:latin typeface="Calibri"/>
               </a:rPr>
-              <a:t>Euronest  |  Business Plan  |  April 2026</a:t>
+              <a:t>Euronest  |  Pitch Deck  |  April 2026</a:t>
             </a:r>
           </a:p>
         </p:txBody>
@@ -23814,7 +23814,7 @@
                 </a:solidFill>
                 <a:latin typeface="Calibri"/>
               </a:rPr>
-              <a:t>Euronest  |  Business Plan  |  April 2026</a:t>
+              <a:t>Euronest  |  Pitch Deck  |  April 2026</a:t>
             </a:r>
           </a:p>
         </p:txBody>

</xml_diff>